<commit_message>
Add Vision and AI model walkthrough
Persist the model that produced each Vision result and clarify historical provenance across the Vision and AI Model Management drafts.

Co-authored-by: Copilot <223556219+Copilot@users.noreply.github.com>
</commit_message>
<xml_diff>
--- a/word-drafts/figures/AiModelManagement-Fig16-Provenance.pptx
+++ b/word-drafts/figures/AiModelManagement-Fig16-Provenance.pptx
@@ -7,7 +7,7 @@
   <p:sldIdLst>
     <p:sldId id="256" r:id="rId7"/>
   </p:sldIdLst>
-  <p:sldSz cx="10401300" cy="4514850" type="screen4x3"/>
+  <p:sldSz cx="10401300" cy="3429000" type="screen4x3"/>
   <p:notesSz cx="6858000" cy="9144000"/>
   <p:defaultTextStyle>
     <a:defPPr>
@@ -3096,7 +3096,7 @@
         </p:nvSpPr>
         <p:spPr>
           <a:xfrm>
-            <a:off x="4105275" y="476250"/>
+            <a:off x="2819400" y="476250"/>
             <a:ext cx="2190750" cy="533400"/>
           </a:xfrm>
           <a:prstGeom prst="rect">
@@ -3189,7 +3189,7 @@
                   <a:srgbClr val="111111"/>
                 </a:solidFill>
               </a:rPr>
-              <a:t>DeploymentType</a:t>
+              <a:t>ModelType</a:t>
             </a:r>
           </a:p>
         </p:txBody>
@@ -3202,7 +3202,7 @@
         </p:nvSpPr>
         <p:spPr>
           <a:xfrm>
-            <a:off x="4105275" y="2647950"/>
+            <a:off x="5391150" y="476250"/>
             <a:ext cx="2190750" cy="533400"/>
           </a:xfrm>
           <a:prstGeom prst="rect">
@@ -3242,7 +3242,7 @@
                   <a:srgbClr val="111111"/>
                 </a:solidFill>
               </a:rPr>
-              <a:t>ModelType</a:t>
+              <a:t>DeploymentType</a:t>
             </a:r>
           </a:p>
         </p:txBody>
@@ -3255,7 +3255,7 @@
         </p:nvSpPr>
         <p:spPr>
           <a:xfrm>
-            <a:off x="247650" y="3733800"/>
+            <a:off x="247650" y="2647950"/>
             <a:ext cx="2190750" cy="533400"/>
           </a:xfrm>
           <a:prstGeom prst="rect">
@@ -3308,7 +3308,7 @@
         </p:nvSpPr>
         <p:spPr>
           <a:xfrm>
-            <a:off x="2819400" y="3733800"/>
+            <a:off x="2819400" y="2647950"/>
             <a:ext cx="2190750" cy="533400"/>
           </a:xfrm>
           <a:prstGeom prst="rect">
@@ -3372,7 +3372,7 @@
         </p:nvSpPr>
         <p:spPr>
           <a:xfrm>
-            <a:off x="5391150" y="3733800"/>
+            <a:off x="5391150" y="2647950"/>
             <a:ext cx="2190750" cy="533400"/>
           </a:xfrm>
           <a:prstGeom prst="rect">
@@ -3425,7 +3425,7 @@
         </p:nvSpPr>
         <p:spPr>
           <a:xfrm>
-            <a:off x="7962900" y="3733800"/>
+            <a:off x="7962900" y="2647950"/>
             <a:ext cx="2190750" cy="533400"/>
           </a:xfrm>
           <a:prstGeom prst="rect">
@@ -3481,8 +3481,8 @@
         </p:nvCxnSpPr>
         <p:spPr>
           <a:xfrm>
-            <a:off x="5200650" y="1009650"/>
-            <a:ext cx="0" cy="552450"/>
+            <a:off x="3914775" y="1009650"/>
+            <a:ext cx="1285875" cy="552450"/>
           </a:xfrm>
           <a:prstGeom prst="line">
             <a:avLst/>
@@ -3508,19 +3508,52 @@
           </a:fontRef>
         </p:style>
       </p:cxnSp>
+      <p:sp>
+        <p:nvSpPr>
+          <p:cNvPr id="10" name="TextBox 9"/>
+          <p:cNvSpPr txBox="1"/>
+          <p:nvPr/>
+        </p:nvSpPr>
+        <p:spPr>
+          <a:xfrm>
+            <a:off x="4595812" y="1228725"/>
+            <a:ext cx="466725" cy="123825"/>
+          </a:xfrm>
+          <a:prstGeom prst="rect">
+            <a:avLst/>
+          </a:prstGeom>
+          <a:noFill/>
+        </p:spPr>
+        <p:txBody>
+          <a:bodyPr wrap="none" lIns="0" rIns="0" tIns="0" bIns="0">
+            <a:spAutoFit/>
+          </a:bodyPr>
+          <a:lstStyle/>
+          <a:p>
+            <a:r>
+              <a:rPr sz="800">
+                <a:solidFill>
+                  <a:srgbClr val="444444"/>
+                </a:solidFill>
+              </a:rPr>
+              <a:t>ModelUsed</a:t>
+            </a:r>
+          </a:p>
+        </p:txBody>
+      </p:sp>
       <p:cxnSp>
         <p:nvCxnSpPr>
-          <p:cNvPr id="10" name="Connector 9"/>
+          <p:cNvPr id="11" name="Connector 10"/>
           <p:cNvCxnSpPr>
-            <a:stCxn id="3" idx="2"/>
-            <a:endCxn id="4" idx="0"/>
+            <a:stCxn id="4" idx="2"/>
+            <a:endCxn id="3" idx="0"/>
           </p:cNvCxnSpPr>
           <p:nvPr/>
         </p:nvCxnSpPr>
         <p:spPr>
-          <a:xfrm>
-            <a:off x="5200650" y="2095500"/>
-            <a:ext cx="0" cy="552450"/>
+          <a:xfrm flipH="1">
+            <a:off x="5200650" y="1009650"/>
+            <a:ext cx="1285875" cy="552450"/>
           </a:xfrm>
           <a:prstGeom prst="line">
             <a:avLst/>
@@ -3548,14 +3581,14 @@
       </p:cxnSp>
       <p:sp>
         <p:nvSpPr>
-          <p:cNvPr id="11" name="TextBox 10"/>
+          <p:cNvPr id="12" name="TextBox 11"/>
           <p:cNvSpPr txBox="1"/>
           <p:nvPr/>
         </p:nvSpPr>
         <p:spPr>
           <a:xfrm>
-            <a:off x="5238750" y="2314575"/>
-            <a:ext cx="1343025" cy="123825"/>
+            <a:off x="5881687" y="1228725"/>
+            <a:ext cx="914400" cy="123825"/>
           </a:xfrm>
           <a:prstGeom prst="rect">
             <a:avLst/>
@@ -3574,28 +3607,28 @@
                   <a:srgbClr val="444444"/>
                 </a:solidFill>
               </a:rPr>
-              <a:t>ModelUsed</a:t>
-            </a:r>
-          </a:p>
-          <a:p>
-            <a:r>
-              <a:t>&lt;b&gt;not&lt;/b&gt; UsesModel</a:t>
+              <a:t>UsesModel</a:t>
+            </a:r>
+          </a:p>
+          <a:p>
+            <a:r>
+              <a:t>serving now</a:t>
             </a:r>
           </a:p>
         </p:txBody>
       </p:sp>
       <p:cxnSp>
         <p:nvCxnSpPr>
-          <p:cNvPr id="12" name="Connector 11"/>
+          <p:cNvPr id="13" name="Connector 12"/>
           <p:cNvCxnSpPr>
-            <a:stCxn id="4" idx="2"/>
+            <a:stCxn id="3" idx="2"/>
             <a:endCxn id="5" idx="0"/>
           </p:cNvCxnSpPr>
           <p:nvPr/>
         </p:nvCxnSpPr>
         <p:spPr>
           <a:xfrm flipH="1">
-            <a:off x="1343025" y="3181350"/>
+            <a:off x="1343025" y="2095500"/>
             <a:ext cx="3857625" cy="552450"/>
           </a:xfrm>
           <a:prstGeom prst="line">
@@ -3624,13 +3657,13 @@
       </p:cxnSp>
       <p:sp>
         <p:nvSpPr>
-          <p:cNvPr id="13" name="TextBox 12"/>
+          <p:cNvPr id="14" name="TextBox 13"/>
           <p:cNvSpPr txBox="1"/>
           <p:nvPr/>
         </p:nvSpPr>
         <p:spPr>
           <a:xfrm>
-            <a:off x="3309937" y="3400425"/>
+            <a:off x="3309937" y="2314575"/>
             <a:ext cx="952500" cy="123825"/>
           </a:xfrm>
           <a:prstGeom prst="rect">
@@ -3657,16 +3690,16 @@
       </p:sp>
       <p:cxnSp>
         <p:nvCxnSpPr>
-          <p:cNvPr id="14" name="Connector 13"/>
+          <p:cNvPr id="15" name="Connector 14"/>
           <p:cNvCxnSpPr>
-            <a:stCxn id="4" idx="2"/>
+            <a:stCxn id="3" idx="2"/>
             <a:endCxn id="6" idx="0"/>
           </p:cNvCxnSpPr>
           <p:nvPr/>
         </p:nvCxnSpPr>
         <p:spPr>
           <a:xfrm flipH="1">
-            <a:off x="3914775" y="3181350"/>
+            <a:off x="3914775" y="2095500"/>
             <a:ext cx="1285875" cy="552450"/>
           </a:xfrm>
           <a:prstGeom prst="line">
@@ -3695,13 +3728,13 @@
       </p:cxnSp>
       <p:sp>
         <p:nvSpPr>
-          <p:cNvPr id="15" name="TextBox 14"/>
+          <p:cNvPr id="16" name="TextBox 15"/>
           <p:cNvSpPr txBox="1"/>
           <p:nvPr/>
         </p:nvSpPr>
         <p:spPr>
           <a:xfrm>
-            <a:off x="4595812" y="3400425"/>
+            <a:off x="4595812" y="2314575"/>
             <a:ext cx="581025" cy="123825"/>
           </a:xfrm>
           <a:prstGeom prst="rect">
@@ -3728,16 +3761,16 @@
       </p:sp>
       <p:cxnSp>
         <p:nvCxnSpPr>
-          <p:cNvPr id="16" name="Connector 15"/>
+          <p:cNvPr id="17" name="Connector 16"/>
           <p:cNvCxnSpPr>
-            <a:stCxn id="4" idx="2"/>
+            <a:stCxn id="3" idx="2"/>
             <a:endCxn id="7" idx="0"/>
           </p:cNvCxnSpPr>
           <p:nvPr/>
         </p:nvCxnSpPr>
         <p:spPr>
           <a:xfrm>
-            <a:off x="5200650" y="3181350"/>
+            <a:off x="5200650" y="2095500"/>
             <a:ext cx="1285875" cy="552450"/>
           </a:xfrm>
           <a:prstGeom prst="line">
@@ -3766,13 +3799,13 @@
       </p:cxnSp>
       <p:sp>
         <p:nvSpPr>
-          <p:cNvPr id="17" name="TextBox 16"/>
+          <p:cNvPr id="18" name="TextBox 17"/>
           <p:cNvSpPr txBox="1"/>
           <p:nvPr/>
         </p:nvSpPr>
         <p:spPr>
           <a:xfrm>
-            <a:off x="5881687" y="3400425"/>
+            <a:off x="5881687" y="2314575"/>
             <a:ext cx="523875" cy="123825"/>
           </a:xfrm>
           <a:prstGeom prst="rect">
@@ -3799,16 +3832,16 @@
       </p:sp>
       <p:cxnSp>
         <p:nvCxnSpPr>
-          <p:cNvPr id="18" name="Connector 17"/>
+          <p:cNvPr id="19" name="Connector 18"/>
           <p:cNvCxnSpPr>
-            <a:stCxn id="4" idx="2"/>
+            <a:stCxn id="3" idx="2"/>
             <a:endCxn id="8" idx="0"/>
           </p:cNvCxnSpPr>
           <p:nvPr/>
         </p:nvCxnSpPr>
         <p:spPr>
           <a:xfrm>
-            <a:off x="5200650" y="3181350"/>
+            <a:off x="5200650" y="2095500"/>
             <a:ext cx="3857625" cy="552450"/>
           </a:xfrm>
           <a:prstGeom prst="line">
@@ -3837,13 +3870,13 @@
       </p:cxnSp>
       <p:sp>
         <p:nvSpPr>
-          <p:cNvPr id="19" name="TextBox 18"/>
+          <p:cNvPr id="20" name="TextBox 19"/>
           <p:cNvSpPr txBox="1"/>
           <p:nvPr/>
         </p:nvSpPr>
         <p:spPr>
           <a:xfrm>
-            <a:off x="7167562" y="3400425"/>
+            <a:off x="7167562" y="2314575"/>
             <a:ext cx="438150" cy="123825"/>
           </a:xfrm>
           <a:prstGeom prst="rect">

</xml_diff>

<commit_message>
Add Vision and AI walkthrough and close provenance gaps (#82)
* Add Vision and AI model walkthrough

Persist the model that produced each Vision result and clarify historical provenance across the Vision and AI Model Management drafts.

Co-authored-by: Copilot <223556219+Copilot@users.noreply.github.com>

* Complete Vision and AI provenance guidance

Add durable AI deployment model-change records, bounded Vision result retention, and a transport-neutral external result mapping. Update the shaded walkthrough and regenerated specification artifacts.

Co-authored-by: Copilot <223556219+Copilot@users.noreply.github.com>

---------

Co-authored-by: Copilot <223556219+Copilot@users.noreply.github.com>
</commit_message>
<xml_diff>
--- a/word-drafts/figures/AiModelManagement-Fig16-Provenance.pptx
+++ b/word-drafts/figures/AiModelManagement-Fig16-Provenance.pptx
@@ -7,7 +7,7 @@
   <p:sldIdLst>
     <p:sldId id="256" r:id="rId7"/>
   </p:sldIdLst>
-  <p:sldSz cx="10401300" cy="4514850" type="screen4x3"/>
+  <p:sldSz cx="10401300" cy="3429000" type="screen4x3"/>
   <p:notesSz cx="6858000" cy="9144000"/>
   <p:defaultTextStyle>
     <a:defPPr>
@@ -3096,7 +3096,7 @@
         </p:nvSpPr>
         <p:spPr>
           <a:xfrm>
-            <a:off x="4105275" y="476250"/>
+            <a:off x="2819400" y="476250"/>
             <a:ext cx="2190750" cy="533400"/>
           </a:xfrm>
           <a:prstGeom prst="rect">
@@ -3189,7 +3189,7 @@
                   <a:srgbClr val="111111"/>
                 </a:solidFill>
               </a:rPr>
-              <a:t>DeploymentType</a:t>
+              <a:t>ModelType</a:t>
             </a:r>
           </a:p>
         </p:txBody>
@@ -3202,7 +3202,7 @@
         </p:nvSpPr>
         <p:spPr>
           <a:xfrm>
-            <a:off x="4105275" y="2647950"/>
+            <a:off x="5391150" y="476250"/>
             <a:ext cx="2190750" cy="533400"/>
           </a:xfrm>
           <a:prstGeom prst="rect">
@@ -3242,7 +3242,7 @@
                   <a:srgbClr val="111111"/>
                 </a:solidFill>
               </a:rPr>
-              <a:t>ModelType</a:t>
+              <a:t>DeploymentType</a:t>
             </a:r>
           </a:p>
         </p:txBody>
@@ -3255,7 +3255,7 @@
         </p:nvSpPr>
         <p:spPr>
           <a:xfrm>
-            <a:off x="247650" y="3733800"/>
+            <a:off x="247650" y="2647950"/>
             <a:ext cx="2190750" cy="533400"/>
           </a:xfrm>
           <a:prstGeom prst="rect">
@@ -3308,7 +3308,7 @@
         </p:nvSpPr>
         <p:spPr>
           <a:xfrm>
-            <a:off x="2819400" y="3733800"/>
+            <a:off x="2819400" y="2647950"/>
             <a:ext cx="2190750" cy="533400"/>
           </a:xfrm>
           <a:prstGeom prst="rect">
@@ -3372,7 +3372,7 @@
         </p:nvSpPr>
         <p:spPr>
           <a:xfrm>
-            <a:off x="5391150" y="3733800"/>
+            <a:off x="5391150" y="2647950"/>
             <a:ext cx="2190750" cy="533400"/>
           </a:xfrm>
           <a:prstGeom prst="rect">
@@ -3425,7 +3425,7 @@
         </p:nvSpPr>
         <p:spPr>
           <a:xfrm>
-            <a:off x="7962900" y="3733800"/>
+            <a:off x="7962900" y="2647950"/>
             <a:ext cx="2190750" cy="533400"/>
           </a:xfrm>
           <a:prstGeom prst="rect">
@@ -3481,8 +3481,8 @@
         </p:nvCxnSpPr>
         <p:spPr>
           <a:xfrm>
-            <a:off x="5200650" y="1009650"/>
-            <a:ext cx="0" cy="552450"/>
+            <a:off x="3914775" y="1009650"/>
+            <a:ext cx="1285875" cy="552450"/>
           </a:xfrm>
           <a:prstGeom prst="line">
             <a:avLst/>
@@ -3508,19 +3508,52 @@
           </a:fontRef>
         </p:style>
       </p:cxnSp>
+      <p:sp>
+        <p:nvSpPr>
+          <p:cNvPr id="10" name="TextBox 9"/>
+          <p:cNvSpPr txBox="1"/>
+          <p:nvPr/>
+        </p:nvSpPr>
+        <p:spPr>
+          <a:xfrm>
+            <a:off x="4595812" y="1228725"/>
+            <a:ext cx="466725" cy="123825"/>
+          </a:xfrm>
+          <a:prstGeom prst="rect">
+            <a:avLst/>
+          </a:prstGeom>
+          <a:noFill/>
+        </p:spPr>
+        <p:txBody>
+          <a:bodyPr wrap="none" lIns="0" rIns="0" tIns="0" bIns="0">
+            <a:spAutoFit/>
+          </a:bodyPr>
+          <a:lstStyle/>
+          <a:p>
+            <a:r>
+              <a:rPr sz="800">
+                <a:solidFill>
+                  <a:srgbClr val="444444"/>
+                </a:solidFill>
+              </a:rPr>
+              <a:t>ModelUsed</a:t>
+            </a:r>
+          </a:p>
+        </p:txBody>
+      </p:sp>
       <p:cxnSp>
         <p:nvCxnSpPr>
-          <p:cNvPr id="10" name="Connector 9"/>
+          <p:cNvPr id="11" name="Connector 10"/>
           <p:cNvCxnSpPr>
-            <a:stCxn id="3" idx="2"/>
-            <a:endCxn id="4" idx="0"/>
+            <a:stCxn id="4" idx="2"/>
+            <a:endCxn id="3" idx="0"/>
           </p:cNvCxnSpPr>
           <p:nvPr/>
         </p:nvCxnSpPr>
         <p:spPr>
-          <a:xfrm>
-            <a:off x="5200650" y="2095500"/>
-            <a:ext cx="0" cy="552450"/>
+          <a:xfrm flipH="1">
+            <a:off x="5200650" y="1009650"/>
+            <a:ext cx="1285875" cy="552450"/>
           </a:xfrm>
           <a:prstGeom prst="line">
             <a:avLst/>
@@ -3548,14 +3581,14 @@
       </p:cxnSp>
       <p:sp>
         <p:nvSpPr>
-          <p:cNvPr id="11" name="TextBox 10"/>
+          <p:cNvPr id="12" name="TextBox 11"/>
           <p:cNvSpPr txBox="1"/>
           <p:nvPr/>
         </p:nvSpPr>
         <p:spPr>
           <a:xfrm>
-            <a:off x="5238750" y="2314575"/>
-            <a:ext cx="1343025" cy="123825"/>
+            <a:off x="5881687" y="1228725"/>
+            <a:ext cx="914400" cy="123825"/>
           </a:xfrm>
           <a:prstGeom prst="rect">
             <a:avLst/>
@@ -3574,28 +3607,28 @@
                   <a:srgbClr val="444444"/>
                 </a:solidFill>
               </a:rPr>
-              <a:t>ModelUsed</a:t>
-            </a:r>
-          </a:p>
-          <a:p>
-            <a:r>
-              <a:t>&lt;b&gt;not&lt;/b&gt; UsesModel</a:t>
+              <a:t>UsesModel</a:t>
+            </a:r>
+          </a:p>
+          <a:p>
+            <a:r>
+              <a:t>serving now</a:t>
             </a:r>
           </a:p>
         </p:txBody>
       </p:sp>
       <p:cxnSp>
         <p:nvCxnSpPr>
-          <p:cNvPr id="12" name="Connector 11"/>
+          <p:cNvPr id="13" name="Connector 12"/>
           <p:cNvCxnSpPr>
-            <a:stCxn id="4" idx="2"/>
+            <a:stCxn id="3" idx="2"/>
             <a:endCxn id="5" idx="0"/>
           </p:cNvCxnSpPr>
           <p:nvPr/>
         </p:nvCxnSpPr>
         <p:spPr>
           <a:xfrm flipH="1">
-            <a:off x="1343025" y="3181350"/>
+            <a:off x="1343025" y="2095500"/>
             <a:ext cx="3857625" cy="552450"/>
           </a:xfrm>
           <a:prstGeom prst="line">
@@ -3624,13 +3657,13 @@
       </p:cxnSp>
       <p:sp>
         <p:nvSpPr>
-          <p:cNvPr id="13" name="TextBox 12"/>
+          <p:cNvPr id="14" name="TextBox 13"/>
           <p:cNvSpPr txBox="1"/>
           <p:nvPr/>
         </p:nvSpPr>
         <p:spPr>
           <a:xfrm>
-            <a:off x="3309937" y="3400425"/>
+            <a:off x="3309937" y="2314575"/>
             <a:ext cx="952500" cy="123825"/>
           </a:xfrm>
           <a:prstGeom prst="rect">
@@ -3657,16 +3690,16 @@
       </p:sp>
       <p:cxnSp>
         <p:nvCxnSpPr>
-          <p:cNvPr id="14" name="Connector 13"/>
+          <p:cNvPr id="15" name="Connector 14"/>
           <p:cNvCxnSpPr>
-            <a:stCxn id="4" idx="2"/>
+            <a:stCxn id="3" idx="2"/>
             <a:endCxn id="6" idx="0"/>
           </p:cNvCxnSpPr>
           <p:nvPr/>
         </p:nvCxnSpPr>
         <p:spPr>
           <a:xfrm flipH="1">
-            <a:off x="3914775" y="3181350"/>
+            <a:off x="3914775" y="2095500"/>
             <a:ext cx="1285875" cy="552450"/>
           </a:xfrm>
           <a:prstGeom prst="line">
@@ -3695,13 +3728,13 @@
       </p:cxnSp>
       <p:sp>
         <p:nvSpPr>
-          <p:cNvPr id="15" name="TextBox 14"/>
+          <p:cNvPr id="16" name="TextBox 15"/>
           <p:cNvSpPr txBox="1"/>
           <p:nvPr/>
         </p:nvSpPr>
         <p:spPr>
           <a:xfrm>
-            <a:off x="4595812" y="3400425"/>
+            <a:off x="4595812" y="2314575"/>
             <a:ext cx="581025" cy="123825"/>
           </a:xfrm>
           <a:prstGeom prst="rect">
@@ -3728,16 +3761,16 @@
       </p:sp>
       <p:cxnSp>
         <p:nvCxnSpPr>
-          <p:cNvPr id="16" name="Connector 15"/>
+          <p:cNvPr id="17" name="Connector 16"/>
           <p:cNvCxnSpPr>
-            <a:stCxn id="4" idx="2"/>
+            <a:stCxn id="3" idx="2"/>
             <a:endCxn id="7" idx="0"/>
           </p:cNvCxnSpPr>
           <p:nvPr/>
         </p:nvCxnSpPr>
         <p:spPr>
           <a:xfrm>
-            <a:off x="5200650" y="3181350"/>
+            <a:off x="5200650" y="2095500"/>
             <a:ext cx="1285875" cy="552450"/>
           </a:xfrm>
           <a:prstGeom prst="line">
@@ -3766,13 +3799,13 @@
       </p:cxnSp>
       <p:sp>
         <p:nvSpPr>
-          <p:cNvPr id="17" name="TextBox 16"/>
+          <p:cNvPr id="18" name="TextBox 17"/>
           <p:cNvSpPr txBox="1"/>
           <p:nvPr/>
         </p:nvSpPr>
         <p:spPr>
           <a:xfrm>
-            <a:off x="5881687" y="3400425"/>
+            <a:off x="5881687" y="2314575"/>
             <a:ext cx="523875" cy="123825"/>
           </a:xfrm>
           <a:prstGeom prst="rect">
@@ -3799,16 +3832,16 @@
       </p:sp>
       <p:cxnSp>
         <p:nvCxnSpPr>
-          <p:cNvPr id="18" name="Connector 17"/>
+          <p:cNvPr id="19" name="Connector 18"/>
           <p:cNvCxnSpPr>
-            <a:stCxn id="4" idx="2"/>
+            <a:stCxn id="3" idx="2"/>
             <a:endCxn id="8" idx="0"/>
           </p:cNvCxnSpPr>
           <p:nvPr/>
         </p:nvCxnSpPr>
         <p:spPr>
           <a:xfrm>
-            <a:off x="5200650" y="3181350"/>
+            <a:off x="5200650" y="2095500"/>
             <a:ext cx="3857625" cy="552450"/>
           </a:xfrm>
           <a:prstGeom prst="line">
@@ -3837,13 +3870,13 @@
       </p:cxnSp>
       <p:sp>
         <p:nvSpPr>
-          <p:cNvPr id="19" name="TextBox 18"/>
+          <p:cNvPr id="20" name="TextBox 19"/>
           <p:cNvSpPr txBox="1"/>
           <p:nvPr/>
         </p:nvSpPr>
         <p:spPr>
           <a:xfrm>
-            <a:off x="7167562" y="3400425"/>
+            <a:off x="7167562" y="2314575"/>
             <a:ext cx="438150" cy="123825"/>
           </a:xfrm>
           <a:prstGeom prst="rect">

</xml_diff>